<commit_message>
발표 ① 코드 슬라이드 정정: 화면(ProductsView)+hook(useCustomerContracts) 분리 — selectProduct·상태는 hook 소속임을 정확히 표시(in-place)
Co-Authored-By: Claude Opus 4.8 <noreply@anthropic.com>
</commit_message>
<xml_diff>
--- a/docs/presentation/보험발표-figma.pptx
+++ b/docs/presentation/보험발표-figma.pptx
@@ -7314,7 +7314,7 @@
                 </a:solidFill>
                 <a:latin typeface="Apple SD Gothic Neo"/>
               </a:rPr>
-              <a:t>프론트 — 버튼 클릭</a:t>
+              <a:t>프론트 — 화면과 hook</a:t>
             </a:r>
           </a:p>
         </p:txBody>
@@ -7360,7 +7360,6 @@
           <a:lstStyle/>
           <a:p>
             <a:pPr algn="ctr"/>
-            <a:endParaRPr/>
           </a:p>
         </p:txBody>
       </p:sp>
@@ -7403,7 +7402,7 @@
                 </a:solidFill>
                 <a:latin typeface="Menlo"/>
               </a:rPr>
-              <a:t>features/contracts/ProductsView.tsx</a:t>
+              <a:t>ProductsView.tsx (화면)  +  useCustomerContracts.ts (hook)</a:t>
             </a:r>
           </a:p>
         </p:txBody>
@@ -7451,7 +7450,6 @@
           <a:lstStyle/>
           <a:p>
             <a:pPr algn="ctr"/>
-            <a:endParaRPr/>
           </a:p>
         </p:txBody>
       </p:sp>
@@ -7485,7 +7483,7 @@
                 </a:solidFill>
                 <a:latin typeface="Menlo"/>
               </a:rPr>
-              <a:t>// 상품 목록의 각 카드</a:t>
+              <a:t>// ProductsView.tsx — 화면: hook에서 받아와 버튼에 연결</a:t>
             </a:r>
           </a:p>
           <a:p>
@@ -7493,11 +7491,23 @@
             <a:r>
               <a:rPr sz="1500" b="0">
                 <a:solidFill>
+                  <a:srgbClr val="CDBFF7"/>
+                </a:solidFill>
+                <a:latin typeface="Menlo"/>
+              </a:rPr>
+              <a:t>const { selectProduct } = state</a:t>
+            </a:r>
+          </a:p>
+          <a:p>
+            <a:pPr algn="l"/>
+            <a:r>
+              <a:rPr sz="1500" b="0">
+                <a:solidFill>
                   <a:srgbClr val="FFFFFF"/>
                 </a:solidFill>
                 <a:latin typeface="Menlo"/>
               </a:rPr>
-              <a:t>&lt;button onClick={() =&gt; selectProduct(product.id)}&gt;</a:t>
+              <a:t>&lt;button onClick={() =&gt; selectProduct(product.id)}&gt;…&lt;/button&gt;</a:t>
             </a:r>
           </a:p>
           <a:p>
@@ -7509,7 +7519,7 @@
                 </a:solidFill>
                 <a:latin typeface="Menlo"/>
               </a:rPr>
-              <a:t>  {product.productName}</a:t>
+              <a:t/>
             </a:r>
           </a:p>
           <a:p>
@@ -7517,52 +7527,31 @@
             <a:r>
               <a:rPr sz="1500" b="0">
                 <a:solidFill>
-                  <a:srgbClr val="FFFFFF"/>
+                  <a:srgbClr val="7C83B0"/>
                 </a:solidFill>
                 <a:latin typeface="Menlo"/>
               </a:rPr>
-              <a:t>&lt;/button&gt;</a:t>
+              <a:t>// useCustomerContracts.ts — hook: 상태 보관 + 호출</a:t>
             </a:r>
           </a:p>
           <a:p>
             <a:pPr algn="l"/>
-            <a:endParaRPr sz="1500" b="0">
-              <a:solidFill>
-                <a:srgbClr val="FFFFFF"/>
-              </a:solidFill>
-              <a:latin typeface="Menlo"/>
-            </a:endParaRPr>
+            <a:r>
+              <a:rPr sz="1500" b="0">
+                <a:solidFill>
+                  <a:srgbClr val="CDBFF7"/>
+                </a:solidFill>
+                <a:latin typeface="Menlo"/>
+              </a:rPr>
+              <a:t>async function selectProduct(id) {</a:t>
+            </a:r>
           </a:p>
           <a:p>
             <a:pPr algn="l"/>
             <a:r>
               <a:rPr sz="1500" b="0">
                 <a:solidFill>
-                  <a:srgbClr val="7C83B0"/>
-                </a:solidFill>
-                <a:latin typeface="Menlo"/>
-              </a:rPr>
-              <a:t>// 클릭하면 실행되는 함수</a:t>
-            </a:r>
-          </a:p>
-          <a:p>
-            <a:pPr algn="l"/>
-            <a:r>
-              <a:rPr sz="1500" b="0">
-                <a:solidFill>
                   <a:srgbClr val="CDBFF7"/>
-                </a:solidFill>
-                <a:latin typeface="Menlo"/>
-              </a:rPr>
-              <a:t>async function selectProduct(id) {</a:t>
-            </a:r>
-          </a:p>
-          <a:p>
-            <a:pPr algn="l"/>
-            <a:r>
-              <a:rPr sz="1500" b="0">
-                <a:solidFill>
-                  <a:srgbClr val="FFFFFF"/>
                 </a:solidFill>
                 <a:latin typeface="Menlo"/>
               </a:rPr>
@@ -7613,7 +7602,7 @@
                 </a:solidFill>
                 <a:latin typeface="Apple SD Gothic Neo"/>
               </a:rPr>
-              <a:t>카드를 누르면 그 상품 id로 selectProduct가 실행된다.</a:t>
+              <a:t>화면의 버튼이 hook의 selectProduct를 호출한다.</a:t>
             </a:r>
           </a:p>
         </p:txBody>

</xml_diff>